<commit_message>
docs: replace deck with corrected 5-term metric decomposition
Slide 1 previously stated an inaccurate 6-term multiplicative
decomposition (Intent x Availability x Price-Certainty x Re-encounter
x Resolution x Checkout). Replaced with the corrected version matching
docs/blueprints/wishlist-conversion-blueprint-v2.md Part B.2's actual
5-term formula, with Price-Certainty now shown as a separate modulating
factor rather than folded into the product.

Verified before committing: 10 slides in both pptx (slide XML count)
and pdf (form-feed page count), zero hits for personal name/email
patterns across pptx XML and pdf text, both files well under the 40MB
limit (177KB / 262KB), pptx core.xml metadata still generic (PptxGenJS).

Co-Authored-By: Claude Sonnet 5 <noreply@anthropic.com>
</commit_message>
<xml_diff>
--- a/docs/deck/NL Myntra.pptx
+++ b/docs/deck/NL Myntra.pptx
@@ -2091,7 +2091,7 @@
         <p:spPr>
           <a:xfrm>
             <a:off x="640080" y="3246120"/>
-            <a:ext cx="1691640" cy="1051560"/>
+            <a:ext cx="1874520" cy="1051560"/>
           </a:xfrm>
           <a:prstGeom prst="roundRect">
             <a:avLst>
@@ -2118,7 +2118,7 @@
         <p:spPr>
           <a:xfrm>
             <a:off x="713232" y="3246120"/>
-            <a:ext cx="1545336" cy="1051560"/>
+            <a:ext cx="1728216" cy="1051560"/>
           </a:xfrm>
           <a:prstGeom prst="rect">
             <a:avLst/>
@@ -2156,8 +2156,8 @@
         </p:nvSpPr>
         <p:spPr>
           <a:xfrm>
-            <a:off x="2331720" y="3246120"/>
-            <a:ext cx="182880" cy="1051560"/>
+            <a:off x="2514600" y="3246120"/>
+            <a:ext cx="201168" cy="1051560"/>
           </a:xfrm>
           <a:prstGeom prst="rect">
             <a:avLst/>
@@ -2195,8 +2195,8 @@
         </p:nvSpPr>
         <p:spPr>
           <a:xfrm>
-            <a:off x="2496312" y="3246120"/>
-            <a:ext cx="1691640" cy="1051560"/>
+            <a:off x="2697480" y="3246120"/>
+            <a:ext cx="1874520" cy="1051560"/>
           </a:xfrm>
           <a:prstGeom prst="roundRect">
             <a:avLst>
@@ -2222,8 +2222,8 @@
         </p:nvSpPr>
         <p:spPr>
           <a:xfrm>
-            <a:off x="2569464" y="3246120"/>
-            <a:ext cx="1545336" cy="1051560"/>
+            <a:off x="2770632" y="3246120"/>
+            <a:ext cx="1728216" cy="1051560"/>
           </a:xfrm>
           <a:prstGeom prst="rect">
             <a:avLst/>
@@ -2261,8 +2261,8 @@
         </p:nvSpPr>
         <p:spPr>
           <a:xfrm>
-            <a:off x="4187952" y="3246120"/>
-            <a:ext cx="182880" cy="1051560"/>
+            <a:off x="4572000" y="3246120"/>
+            <a:ext cx="201168" cy="1051560"/>
           </a:xfrm>
           <a:prstGeom prst="rect">
             <a:avLst/>
@@ -2300,8 +2300,8 @@
         </p:nvSpPr>
         <p:spPr>
           <a:xfrm>
-            <a:off x="4352544" y="3246120"/>
-            <a:ext cx="1691640" cy="1051560"/>
+            <a:off x="4754880" y="3246120"/>
+            <a:ext cx="1874520" cy="1051560"/>
           </a:xfrm>
           <a:prstGeom prst="roundRect">
             <a:avLst>
@@ -2327,8 +2327,8 @@
         </p:nvSpPr>
         <p:spPr>
           <a:xfrm>
-            <a:off x="4425696" y="3246120"/>
-            <a:ext cx="1545336" cy="1051560"/>
+            <a:off x="4828032" y="3246120"/>
+            <a:ext cx="1728216" cy="1051560"/>
           </a:xfrm>
           <a:prstGeom prst="rect">
             <a:avLst/>
@@ -2352,7 +2352,7 @@
                 <a:ea typeface="Calibri" pitchFamily="34" charset="-122"/>
                 <a:cs typeface="Calibri" pitchFamily="34" charset="-120"/>
               </a:rPr>
-              <a:t>Price-Certainty</a:t>
+              <a:t>Re-encounter</a:t>
             </a:r>
             <a:endParaRPr lang="en-US" sz="1400" dirty="0"/>
           </a:p>
@@ -2366,8 +2366,8 @@
         </p:nvSpPr>
         <p:spPr>
           <a:xfrm>
-            <a:off x="6044184" y="3246120"/>
-            <a:ext cx="182880" cy="1051560"/>
+            <a:off x="6629400" y="3246120"/>
+            <a:ext cx="201168" cy="1051560"/>
           </a:xfrm>
           <a:prstGeom prst="rect">
             <a:avLst/>
@@ -2405,8 +2405,8 @@
         </p:nvSpPr>
         <p:spPr>
           <a:xfrm>
-            <a:off x="6208776" y="3246120"/>
-            <a:ext cx="1691640" cy="1051560"/>
+            <a:off x="6812280" y="3246120"/>
+            <a:ext cx="1874520" cy="1051560"/>
           </a:xfrm>
           <a:prstGeom prst="roundRect">
             <a:avLst>
@@ -2432,8 +2432,8 @@
         </p:nvSpPr>
         <p:spPr>
           <a:xfrm>
-            <a:off x="6281928" y="3246120"/>
-            <a:ext cx="1545336" cy="1051560"/>
+            <a:off x="6885432" y="3246120"/>
+            <a:ext cx="1728216" cy="1051560"/>
           </a:xfrm>
           <a:prstGeom prst="rect">
             <a:avLst/>
@@ -2457,7 +2457,7 @@
                 <a:ea typeface="Calibri" pitchFamily="34" charset="-122"/>
                 <a:cs typeface="Calibri" pitchFamily="34" charset="-120"/>
               </a:rPr>
-              <a:t>Re-encounter</a:t>
+              <a:t>Resolution</a:t>
             </a:r>
             <a:endParaRPr lang="en-US" sz="1400" dirty="0"/>
           </a:p>
@@ -2471,8 +2471,8 @@
         </p:nvSpPr>
         <p:spPr>
           <a:xfrm>
-            <a:off x="7900416" y="3246120"/>
-            <a:ext cx="182880" cy="1051560"/>
+            <a:off x="8686800" y="3246120"/>
+            <a:ext cx="201168" cy="1051560"/>
           </a:xfrm>
           <a:prstGeom prst="rect">
             <a:avLst/>
@@ -2510,8 +2510,8 @@
         </p:nvSpPr>
         <p:spPr>
           <a:xfrm>
-            <a:off x="8065008" y="3246120"/>
-            <a:ext cx="1691640" cy="1051560"/>
+            <a:off x="8869680" y="3246120"/>
+            <a:ext cx="1874520" cy="1051560"/>
           </a:xfrm>
           <a:prstGeom prst="roundRect">
             <a:avLst>
@@ -2537,8 +2537,8 @@
         </p:nvSpPr>
         <p:spPr>
           <a:xfrm>
-            <a:off x="8138160" y="3246120"/>
-            <a:ext cx="1545336" cy="1051560"/>
+            <a:off x="8942832" y="3246120"/>
+            <a:ext cx="1728216" cy="1051560"/>
           </a:xfrm>
           <a:prstGeom prst="rect">
             <a:avLst/>
@@ -2562,7 +2562,7 @@
                 <a:ea typeface="Calibri" pitchFamily="34" charset="-122"/>
                 <a:cs typeface="Calibri" pitchFamily="34" charset="-120"/>
               </a:rPr>
-              <a:t>Resolution</a:t>
+              <a:t>Checkout</a:t>
             </a:r>
             <a:endParaRPr lang="en-US" sz="1400" dirty="0"/>
           </a:p>
@@ -2570,65 +2570,26 @@
       </p:sp>
       <p:sp>
         <p:nvSpPr>
-          <p:cNvPr id="19" name="Text 17"/>
-          <p:cNvSpPr txBox="1"/>
-          <p:nvPr/>
-        </p:nvSpPr>
-        <p:spPr>
-          <a:xfrm>
-            <a:off x="9756648" y="3246120"/>
-            <a:ext cx="182880" cy="1051560"/>
-          </a:xfrm>
-          <a:prstGeom prst="rect">
-            <a:avLst/>
-          </a:prstGeom>
-          <a:noFill/>
-          <a:ln/>
-        </p:spPr>
-        <p:txBody>
-          <a:bodyPr wrap="square" lIns="0" tIns="0" rIns="0" bIns="0" rtlCol="0" anchor="ctr"/>
-          <a:lstStyle/>
-          <a:p>
-            <a:pPr algn="ctr" indent="0" marL="0">
-              <a:buNone/>
-            </a:pPr>
-            <a:r>
-              <a:rPr lang="en-US" sz="1600" dirty="0">
-                <a:solidFill>
-                  <a:srgbClr val="B5822A"/>
-                </a:solidFill>
-                <a:latin typeface="Calibri" pitchFamily="34" charset="0"/>
-                <a:ea typeface="Calibri" pitchFamily="34" charset="-122"/>
-                <a:cs typeface="Calibri" pitchFamily="34" charset="-120"/>
-              </a:rPr>
-              <a:t>→</a:t>
-            </a:r>
-            <a:endParaRPr lang="en-US" sz="1600" dirty="0"/>
-          </a:p>
-        </p:txBody>
-      </p:sp>
-      <p:sp>
-        <p:nvSpPr>
-          <p:cNvPr id="20" name="Shape 18"/>
+          <p:cNvPr id="19" name="Shape 17"/>
           <p:cNvSpPr/>
           <p:nvPr/>
         </p:nvSpPr>
         <p:spPr>
           <a:xfrm>
-            <a:off x="9921240" y="3246120"/>
-            <a:ext cx="1691640" cy="1051560"/>
+            <a:off x="640080" y="4572000"/>
+            <a:ext cx="10104120" cy="594360"/>
           </a:xfrm>
           <a:prstGeom prst="roundRect">
             <a:avLst>
-              <a:gd name="adj" fmla="val 6957"/>
+              <a:gd name="adj" fmla="val 12308"/>
             </a:avLst>
           </a:prstGeom>
           <a:solidFill>
             <a:srgbClr val="6E4A5B"/>
           </a:solidFill>
-          <a:ln w="6350">
+          <a:ln w="12700">
             <a:solidFill>
-              <a:srgbClr val="6E4A5B"/>
+              <a:srgbClr val="B5822A"/>
             </a:solidFill>
             <a:prstDash val="solid"/>
           </a:ln>
@@ -2636,53 +2597,53 @@
       </p:sp>
       <p:sp>
         <p:nvSpPr>
+          <p:cNvPr id="20" name="Text 18"/>
+          <p:cNvSpPr txBox="1"/>
+          <p:nvPr/>
+        </p:nvSpPr>
+        <p:spPr>
+          <a:xfrm>
+            <a:off x="868680" y="4572000"/>
+            <a:ext cx="9646920" cy="594360"/>
+          </a:xfrm>
+          <a:prstGeom prst="rect">
+            <a:avLst/>
+          </a:prstGeom>
+          <a:noFill/>
+          <a:ln/>
+        </p:spPr>
+        <p:txBody>
+          <a:bodyPr wrap="square" lIns="0" tIns="0" rIns="0" bIns="0" rtlCol="0" anchor="ctr"/>
+          <a:lstStyle/>
+          <a:p>
+            <a:pPr algn="ctr" indent="0" marL="0">
+              <a:buNone/>
+            </a:pPr>
+            <a:r>
+              <a:rPr lang="en-US" sz="1400" i="1" dirty="0">
+                <a:solidFill>
+                  <a:srgbClr val="E9DFD3"/>
+                </a:solidFill>
+                <a:latin typeface="Calibri" pitchFamily="34" charset="0"/>
+                <a:ea typeface="Calibri" pitchFamily="34" charset="-122"/>
+                <a:cs typeface="Calibri" pitchFamily="34" charset="-120"/>
+              </a:rPr>
+              <a:t>+ Price-Certainty — a soft hesitation factor that modulates Resolution, not a hard sequential gate like Availability</a:t>
+            </a:r>
+            <a:endParaRPr lang="en-US" sz="1400" dirty="0"/>
+          </a:p>
+        </p:txBody>
+      </p:sp>
+      <p:sp>
+        <p:nvSpPr>
           <p:cNvPr id="21" name="Text 19"/>
           <p:cNvSpPr txBox="1"/>
           <p:nvPr/>
         </p:nvSpPr>
         <p:spPr>
           <a:xfrm>
-            <a:off x="9994392" y="3246120"/>
-            <a:ext cx="1545336" cy="1051560"/>
-          </a:xfrm>
-          <a:prstGeom prst="rect">
-            <a:avLst/>
-          </a:prstGeom>
-          <a:noFill/>
-          <a:ln/>
-        </p:spPr>
-        <p:txBody>
-          <a:bodyPr wrap="square" lIns="0" tIns="0" rIns="0" bIns="0" rtlCol="0" anchor="ctr"/>
-          <a:lstStyle/>
-          <a:p>
-            <a:pPr algn="ctr" indent="0" marL="0">
-              <a:buNone/>
-            </a:pPr>
-            <a:r>
-              <a:rPr lang="en-US" sz="1400" b="1" dirty="0">
-                <a:solidFill>
-                  <a:srgbClr val="F6F1EA"/>
-                </a:solidFill>
-                <a:latin typeface="Calibri" pitchFamily="34" charset="0"/>
-                <a:ea typeface="Calibri" pitchFamily="34" charset="-122"/>
-                <a:cs typeface="Calibri" pitchFamily="34" charset="-120"/>
-              </a:rPr>
-              <a:t>Checkout</a:t>
-            </a:r>
-            <a:endParaRPr lang="en-US" sz="1400" dirty="0"/>
-          </a:p>
-        </p:txBody>
-      </p:sp>
-      <p:sp>
-        <p:nvSpPr>
-          <p:cNvPr id="22" name="Text 20"/>
-          <p:cNvSpPr txBox="1"/>
-          <p:nvPr/>
-        </p:nvSpPr>
-        <p:spPr>
-          <a:xfrm>
-            <a:off x="640080" y="4663440"/>
-            <a:ext cx="10058400" cy="822960"/>
+            <a:off x="640080" y="5349240"/>
+            <a:ext cx="10058400" cy="777240"/>
           </a:xfrm>
           <a:prstGeom prst="rect">
             <a:avLst/>
@@ -2717,7 +2678,7 @@
       </p:sp>
       <p:sp>
         <p:nvSpPr>
-          <p:cNvPr id="23" name="Text 21"/>
+          <p:cNvPr id="22" name="Text 20"/>
           <p:cNvSpPr txBox="1"/>
           <p:nvPr/>
         </p:nvSpPr>
@@ -2756,7 +2717,7 @@
       </p:sp>
       <p:sp>
         <p:nvSpPr>
-          <p:cNvPr id="24" name="Text 22"/>
+          <p:cNvPr id="23" name="Text 21"/>
           <p:cNvSpPr txBox="1"/>
           <p:nvPr/>
         </p:nvSpPr>
@@ -7885,7 +7846,7 @@
                 <a:ea typeface="Calibri" pitchFamily="34" charset="-122"/>
                 <a:cs typeface="Calibri" pitchFamily="34" charset="-120"/>
               </a:rPr>
-              <a:t>Wishlist Grid</a:t>
+              <a:t>Wishlist Intelligence</a:t>
             </a:r>
             <a:endParaRPr lang="en-US" sz="1400" dirty="0"/>
           </a:p>
@@ -8095,7 +8056,7 @@
                 <a:ea typeface="Calibri" pitchFamily="34" charset="-122"/>
                 <a:cs typeface="Calibri" pitchFamily="34" charset="-120"/>
               </a:rPr>
-              <a:t>AI Trace Widget</a:t>
+              <a:t>Decision Check</a:t>
             </a:r>
             <a:endParaRPr lang="en-US" sz="1400" dirty="0"/>
           </a:p>

</xml_diff>